<commit_message>
Presentaciones antes de Temas
</commit_message>
<xml_diff>
--- a/02-PROFESORADO/03-PRESENTACIONES/00-presentacion-inicial-programacion-entornos.pptx
+++ b/02-PROFESORADO/03-PRESENTACIONES/00-presentacion-inicial-programacion-entornos.pptx
@@ -5628,8 +5628,8 @@
         </p:nvSpPr>
         <p:spPr>
           <a:xfrm>
-            <a:off x="731520" y="1371600"/>
-            <a:ext cx="5120640" cy="2011680"/>
+            <a:off x="731520" y="1207008"/>
+            <a:ext cx="10607040" cy="713232"/>
           </a:xfrm>
           <a:prstGeom prst="roundRect">
             <a:avLst/>
@@ -5673,8 +5673,8 @@
         </p:nvSpPr>
         <p:spPr>
           <a:xfrm>
-            <a:off x="1005840" y="1645920"/>
-            <a:ext cx="4572000" cy="1463040"/>
+            <a:off x="960120" y="1280160"/>
+            <a:ext cx="10149840" cy="548640"/>
           </a:xfrm>
           <a:prstGeom prst="rect">
             <a:avLst/>
@@ -5682,14 +5682,14 @@
           <a:noFill/>
         </p:spPr>
         <p:txBody>
-          <a:bodyPr wrap="square">
+          <a:bodyPr wrap="square" anchor="t" lIns="18288" rIns="18288" tIns="9144" bIns="9144">
             <a:spAutoFit/>
           </a:bodyPr>
           <a:lstStyle/>
           <a:p>
             <a:pPr>
               <a:spcAft>
-                <a:spcPts val="1000"/>
+                <a:spcPts val="400"/>
               </a:spcAft>
               <a:defRPr sz="1800" b="1">
                 <a:solidFill>
@@ -5698,11 +5698,15 @@
               </a:defRPr>
             </a:pPr>
             <a:r>
-              <a:t>H — Hecho / Reto</a:t>
+              <a:rPr sz="1500" b="1"/>
+              <a:t>Fase 0 — Equipos</a:t>
             </a:r>
           </a:p>
           <a:p>
             <a:pPr>
+              <a:spcAft>
+                <a:spcPts val="0"/>
+              </a:spcAft>
               <a:defRPr sz="1400">
                 <a:solidFill>
                   <a:srgbClr val="28323C"/>
@@ -5710,7 +5714,8 @@
               </a:defRPr>
             </a:pPr>
             <a:r>
-              <a:t>Comprender el problema y los criterios de éxito.</a:t>
+              <a:rPr sz="1050" b="0"/>
+              <a:t>Base transversal: equipos estables, roles, normas y responsabilidad compartida.</a:t>
             </a:r>
           </a:p>
         </p:txBody>
@@ -5723,8 +5728,8 @@
         </p:nvSpPr>
         <p:spPr>
           <a:xfrm>
-            <a:off x="6217920" y="1371600"/>
-            <a:ext cx="5120640" cy="2011680"/>
+            <a:off x="731520" y="2176272"/>
+            <a:ext cx="3401568" cy="1664208"/>
           </a:xfrm>
           <a:prstGeom prst="roundRect">
             <a:avLst/>
@@ -5768,8 +5773,8 @@
         </p:nvSpPr>
         <p:spPr>
           <a:xfrm>
-            <a:off x="6492240" y="1645920"/>
-            <a:ext cx="4572000" cy="1463040"/>
+            <a:off x="941832" y="2359152"/>
+            <a:ext cx="2980944" cy="1298448"/>
           </a:xfrm>
           <a:prstGeom prst="rect">
             <a:avLst/>
@@ -5777,14 +5782,14 @@
           <a:noFill/>
         </p:spPr>
         <p:txBody>
-          <a:bodyPr wrap="square">
+          <a:bodyPr wrap="square" anchor="t" lIns="18288" rIns="18288" tIns="9144" bIns="9144">
             <a:spAutoFit/>
           </a:bodyPr>
           <a:lstStyle/>
           <a:p>
             <a:pPr>
               <a:spcAft>
-                <a:spcPts val="1000"/>
+                <a:spcPts val="400"/>
               </a:spcAft>
               <a:defRPr sz="1800" b="1">
                 <a:solidFill>
@@ -5793,11 +5798,15 @@
               </a:defRPr>
             </a:pPr>
             <a:r>
-              <a:t>E — Exploración</a:t>
+              <a:rPr sz="1600" b="1"/>
+              <a:t>1 — Activar</a:t>
             </a:r>
           </a:p>
           <a:p>
             <a:pPr>
+              <a:spcAft>
+                <a:spcPts val="0"/>
+              </a:spcAft>
               <a:defRPr sz="1400">
                 <a:solidFill>
                   <a:srgbClr val="28323C"/>
@@ -5805,7 +5814,8 @@
               </a:defRPr>
             </a:pPr>
             <a:r>
-              <a:t>Probar alternativas y formular hipótesis.</a:t>
+              <a:rPr sz="1150" b="0"/>
+              <a:t>Entender el reto y acordar objetivos y criterios de éxito.</a:t>
             </a:r>
           </a:p>
         </p:txBody>
@@ -5818,8 +5828,8 @@
         </p:nvSpPr>
         <p:spPr>
           <a:xfrm>
-            <a:off x="731520" y="3749039"/>
-            <a:ext cx="5120640" cy="2011680"/>
+            <a:off x="4398264" y="2176272"/>
+            <a:ext cx="3401568" cy="1664208"/>
           </a:xfrm>
           <a:prstGeom prst="roundRect">
             <a:avLst/>
@@ -5863,8 +5873,8 @@
         </p:nvSpPr>
         <p:spPr>
           <a:xfrm>
-            <a:off x="1005840" y="4023359"/>
-            <a:ext cx="4572000" cy="1463040"/>
+            <a:off x="4608576" y="2359152"/>
+            <a:ext cx="2980944" cy="1298448"/>
           </a:xfrm>
           <a:prstGeom prst="rect">
             <a:avLst/>
@@ -5872,14 +5882,14 @@
           <a:noFill/>
         </p:spPr>
         <p:txBody>
-          <a:bodyPr wrap="square">
+          <a:bodyPr wrap="square" anchor="t" lIns="18288" rIns="18288" tIns="9144" bIns="9144">
             <a:spAutoFit/>
           </a:bodyPr>
           <a:lstStyle/>
           <a:p>
             <a:pPr>
               <a:spcAft>
-                <a:spcPts val="1000"/>
+                <a:spcPts val="400"/>
               </a:spcAft>
               <a:defRPr sz="1800" b="1">
                 <a:solidFill>
@@ -5888,11 +5898,15 @@
               </a:defRPr>
             </a:pPr>
             <a:r>
-              <a:t>X — eXplicación</a:t>
+              <a:rPr sz="1600" b="1"/>
+              <a:t>2 — Investigar</a:t>
             </a:r>
           </a:p>
           <a:p>
             <a:pPr>
+              <a:spcAft>
+                <a:spcPts val="0"/>
+              </a:spcAft>
               <a:defRPr sz="1400">
                 <a:solidFill>
                   <a:srgbClr val="28323C"/>
@@ -5900,7 +5914,8 @@
               </a:defRPr>
             </a:pPr>
             <a:r>
-              <a:t>Formalizar los conceptos con la guía docente.</a:t>
+              <a:rPr sz="1150" b="0"/>
+              <a:t>Adquirir los conocimientos necesarios con búsqueda y guía docente.</a:t>
             </a:r>
           </a:p>
         </p:txBody>
@@ -5913,8 +5928,8 @@
         </p:nvSpPr>
         <p:spPr>
           <a:xfrm>
-            <a:off x="6217920" y="3749039"/>
-            <a:ext cx="5120640" cy="2011680"/>
+            <a:off x="8065008" y="2176272"/>
+            <a:ext cx="3401568" cy="1664208"/>
           </a:xfrm>
           <a:prstGeom prst="roundRect">
             <a:avLst/>
@@ -5958,8 +5973,8 @@
         </p:nvSpPr>
         <p:spPr>
           <a:xfrm>
-            <a:off x="6492240" y="4023359"/>
-            <a:ext cx="4572000" cy="1463040"/>
+            <a:off x="8275320" y="2359152"/>
+            <a:ext cx="2980944" cy="1298448"/>
           </a:xfrm>
           <a:prstGeom prst="rect">
             <a:avLst/>
@@ -5967,14 +5982,14 @@
           <a:noFill/>
         </p:spPr>
         <p:txBody>
-          <a:bodyPr wrap="square">
+          <a:bodyPr wrap="square" anchor="t" lIns="18288" rIns="18288" tIns="9144" bIns="9144">
             <a:spAutoFit/>
           </a:bodyPr>
           <a:lstStyle/>
           <a:p>
             <a:pPr>
               <a:spcAft>
-                <a:spcPts val="1000"/>
+                <a:spcPts val="400"/>
               </a:spcAft>
               <a:defRPr sz="1800" b="1">
                 <a:solidFill>
@@ -5983,11 +5998,15 @@
               </a:defRPr>
             </a:pPr>
             <a:r>
-              <a:t>A — Aplicación</a:t>
+              <a:rPr sz="1600" b="1"/>
+              <a:t>3 — Idear</a:t>
             </a:r>
           </a:p>
           <a:p>
             <a:pPr>
+              <a:spcAft>
+                <a:spcPts val="0"/>
+              </a:spcAft>
               <a:defRPr sz="1400">
                 <a:solidFill>
                   <a:srgbClr val="28323C"/>
@@ -5995,7 +6014,308 @@
               </a:defRPr>
             </a:pPr>
             <a:r>
-              <a:t>Construir, probar, documentar, defender y mejorar.</a:t>
+              <a:rPr sz="1150" b="0"/>
+              <a:t>Generar alternativas y elegir una solución con criterios.</a:t>
+            </a:r>
+          </a:p>
+        </p:txBody>
+      </p:sp>
+      <p:sp>
+        <p:nvSpPr>
+          <p:cNvPr id="12" name="HEXA card 5"/>
+          <p:cNvSpPr/>
+          <p:nvPr/>
+        </p:nvSpPr>
+        <p:spPr>
+          <a:xfrm>
+            <a:off x="731520" y="4206240"/>
+            <a:ext cx="3401568" cy="1664208"/>
+          </a:xfrm>
+          <a:prstGeom prst="roundRect">
+            <a:avLst/>
+          </a:prstGeom>
+          <a:solidFill>
+            <a:srgbClr val="F5F7FA"/>
+          </a:solidFill>
+          <a:ln w="19050">
+            <a:solidFill>
+              <a:srgbClr val="009688"/>
+            </a:solidFill>
+          </a:ln>
+        </p:spPr>
+        <p:style>
+          <a:lnRef idx="1">
+            <a:schemeClr val="accent1"/>
+          </a:lnRef>
+          <a:fillRef idx="3">
+            <a:schemeClr val="accent1"/>
+          </a:fillRef>
+          <a:effectRef idx="2">
+            <a:schemeClr val="accent1"/>
+          </a:effectRef>
+          <a:fontRef idx="minor">
+            <a:schemeClr val="lt1"/>
+          </a:fontRef>
+        </p:style>
+        <p:txBody>
+          <a:bodyPr rtlCol="0" anchor="ctr"/>
+          <a:lstStyle/>
+          <a:p>
+            <a:pPr algn="ctr"/>
+          </a:p>
+        </p:txBody>
+      </p:sp>
+      <p:sp>
+        <p:nvSpPr>
+          <p:cNvPr id="13" name="HEXA text 5"/>
+          <p:cNvSpPr txBox="1"/>
+          <p:nvPr/>
+        </p:nvSpPr>
+        <p:spPr>
+          <a:xfrm>
+            <a:off x="941832" y="4389120"/>
+            <a:ext cx="2980944" cy="1298448"/>
+          </a:xfrm>
+          <a:prstGeom prst="rect">
+            <a:avLst/>
+          </a:prstGeom>
+          <a:noFill/>
+        </p:spPr>
+        <p:txBody>
+          <a:bodyPr wrap="square" anchor="t" lIns="18288" rIns="18288" tIns="9144" bIns="9144">
+            <a:spAutoFit/>
+          </a:bodyPr>
+          <a:lstStyle/>
+          <a:p>
+            <a:pPr>
+              <a:spcAft>
+                <a:spcPts val="400"/>
+              </a:spcAft>
+              <a:defRPr sz="1800" b="1">
+                <a:solidFill>
+                  <a:srgbClr val="18202A"/>
+                </a:solidFill>
+              </a:defRPr>
+            </a:pPr>
+            <a:r>
+              <a:rPr sz="1600" b="1"/>
+              <a:t>4 — Planificar</a:t>
+            </a:r>
+          </a:p>
+          <a:p>
+            <a:pPr>
+              <a:spcAft>
+                <a:spcPts val="0"/>
+              </a:spcAft>
+              <a:defRPr sz="1400">
+                <a:solidFill>
+                  <a:srgbClr val="28323C"/>
+                </a:solidFill>
+              </a:defRPr>
+            </a:pPr>
+            <a:r>
+              <a:rPr sz="1150" b="0"/>
+              <a:t>Organizar tareas, tiempos, responsables y seguimiento.</a:t>
+            </a:r>
+          </a:p>
+        </p:txBody>
+      </p:sp>
+      <p:sp>
+        <p:nvSpPr>
+          <p:cNvPr id="14" name="HEXA card 6"/>
+          <p:cNvSpPr/>
+          <p:nvPr/>
+        </p:nvSpPr>
+        <p:spPr>
+          <a:xfrm>
+            <a:off x="4398264" y="4206240"/>
+            <a:ext cx="3401568" cy="1664208"/>
+          </a:xfrm>
+          <a:prstGeom prst="roundRect">
+            <a:avLst/>
+          </a:prstGeom>
+          <a:solidFill>
+            <a:srgbClr val="F5F7FA"/>
+          </a:solidFill>
+          <a:ln w="19050">
+            <a:solidFill>
+              <a:srgbClr val="009688"/>
+            </a:solidFill>
+          </a:ln>
+        </p:spPr>
+        <p:style>
+          <a:lnRef idx="1">
+            <a:schemeClr val="accent1"/>
+          </a:lnRef>
+          <a:fillRef idx="3">
+            <a:schemeClr val="accent1"/>
+          </a:fillRef>
+          <a:effectRef idx="2">
+            <a:schemeClr val="accent1"/>
+          </a:effectRef>
+          <a:fontRef idx="minor">
+            <a:schemeClr val="lt1"/>
+          </a:fontRef>
+        </p:style>
+        <p:txBody>
+          <a:bodyPr rtlCol="0" anchor="ctr"/>
+          <a:lstStyle/>
+          <a:p>
+            <a:pPr algn="ctr"/>
+          </a:p>
+        </p:txBody>
+      </p:sp>
+      <p:sp>
+        <p:nvSpPr>
+          <p:cNvPr id="15" name="HEXA text 6"/>
+          <p:cNvSpPr txBox="1"/>
+          <p:nvPr/>
+        </p:nvSpPr>
+        <p:spPr>
+          <a:xfrm>
+            <a:off x="4608576" y="4389120"/>
+            <a:ext cx="2980944" cy="1298448"/>
+          </a:xfrm>
+          <a:prstGeom prst="rect">
+            <a:avLst/>
+          </a:prstGeom>
+          <a:noFill/>
+        </p:spPr>
+        <p:txBody>
+          <a:bodyPr wrap="square" anchor="t" lIns="18288" rIns="18288" tIns="9144" bIns="9144">
+            <a:spAutoFit/>
+          </a:bodyPr>
+          <a:lstStyle/>
+          <a:p>
+            <a:pPr>
+              <a:spcAft>
+                <a:spcPts val="400"/>
+              </a:spcAft>
+              <a:defRPr sz="1800" b="1">
+                <a:solidFill>
+                  <a:srgbClr val="18202A"/>
+                </a:solidFill>
+              </a:defRPr>
+            </a:pPr>
+            <a:r>
+              <a:rPr sz="1600" b="1"/>
+              <a:t>5 — Ejecutar</a:t>
+            </a:r>
+          </a:p>
+          <a:p>
+            <a:pPr>
+              <a:spcAft>
+                <a:spcPts val="0"/>
+              </a:spcAft>
+              <a:defRPr sz="1400">
+                <a:solidFill>
+                  <a:srgbClr val="28323C"/>
+                </a:solidFill>
+              </a:defRPr>
+            </a:pPr>
+            <a:r>
+              <a:rPr sz="1150" b="0"/>
+              <a:t>Construir, probar e iterar el producto y sus evidencias.</a:t>
+            </a:r>
+          </a:p>
+        </p:txBody>
+      </p:sp>
+      <p:sp>
+        <p:nvSpPr>
+          <p:cNvPr id="16" name="HEXA card 7"/>
+          <p:cNvSpPr/>
+          <p:nvPr/>
+        </p:nvSpPr>
+        <p:spPr>
+          <a:xfrm>
+            <a:off x="8065008" y="4206240"/>
+            <a:ext cx="3401568" cy="1664208"/>
+          </a:xfrm>
+          <a:prstGeom prst="roundRect">
+            <a:avLst/>
+          </a:prstGeom>
+          <a:solidFill>
+            <a:srgbClr val="F5F7FA"/>
+          </a:solidFill>
+          <a:ln w="19050">
+            <a:solidFill>
+              <a:srgbClr val="009688"/>
+            </a:solidFill>
+          </a:ln>
+        </p:spPr>
+        <p:style>
+          <a:lnRef idx="1">
+            <a:schemeClr val="accent1"/>
+          </a:lnRef>
+          <a:fillRef idx="3">
+            <a:schemeClr val="accent1"/>
+          </a:fillRef>
+          <a:effectRef idx="2">
+            <a:schemeClr val="accent1"/>
+          </a:effectRef>
+          <a:fontRef idx="minor">
+            <a:schemeClr val="lt1"/>
+          </a:fontRef>
+        </p:style>
+        <p:txBody>
+          <a:bodyPr rtlCol="0" anchor="ctr"/>
+          <a:lstStyle/>
+          <a:p>
+            <a:pPr algn="ctr"/>
+          </a:p>
+        </p:txBody>
+      </p:sp>
+      <p:sp>
+        <p:nvSpPr>
+          <p:cNvPr id="17" name="HEXA text 7"/>
+          <p:cNvSpPr txBox="1"/>
+          <p:nvPr/>
+        </p:nvSpPr>
+        <p:spPr>
+          <a:xfrm>
+            <a:off x="8275320" y="4389120"/>
+            <a:ext cx="2980944" cy="1298448"/>
+          </a:xfrm>
+          <a:prstGeom prst="rect">
+            <a:avLst/>
+          </a:prstGeom>
+          <a:noFill/>
+        </p:spPr>
+        <p:txBody>
+          <a:bodyPr wrap="square" anchor="t" lIns="18288" rIns="18288" tIns="9144" bIns="9144">
+            <a:spAutoFit/>
+          </a:bodyPr>
+          <a:lstStyle/>
+          <a:p>
+            <a:pPr>
+              <a:spcAft>
+                <a:spcPts val="400"/>
+              </a:spcAft>
+              <a:defRPr sz="1800" b="1">
+                <a:solidFill>
+                  <a:srgbClr val="18202A"/>
+                </a:solidFill>
+              </a:defRPr>
+            </a:pPr>
+            <a:r>
+              <a:rPr sz="1600" b="1"/>
+              <a:t>6 — Comunicar</a:t>
+            </a:r>
+          </a:p>
+          <a:p>
+            <a:pPr>
+              <a:spcAft>
+                <a:spcPts val="0"/>
+              </a:spcAft>
+              <a:defRPr sz="1400">
+                <a:solidFill>
+                  <a:srgbClr val="28323C"/>
+                </a:solidFill>
+              </a:defRPr>
+            </a:pPr>
+            <a:r>
+              <a:rPr sz="1150" b="0"/>
+              <a:t>Presentar, evaluar, reflexionar y proponer mejoras.</a:t>
             </a:r>
           </a:p>
         </p:txBody>

</xml_diff>